<commit_message>
feat: add patch_shakti_sdk_for_spike.sh and exact untouched hello.c with dual-target uart.h
</commit_message>
<xml_diff>
--- a/final_touch/SHAKTI_User_Manual_Slides.pptx
+++ b/final_touch/SHAKTI_User_Manual_Slides.pptx
@@ -5,20 +5,20 @@
     <p:sldMasterId id="2147483648" r:id="rId1"/>
   </p:sldMasterIdLst>
   <p:sldIdLst>
-    <p:sldId id="256" r:id="rId7"/>
-    <p:sldId id="257" r:id="rId8"/>
-    <p:sldId id="258" r:id="rId9"/>
-    <p:sldId id="259" r:id="rId10"/>
-    <p:sldId id="260" r:id="rId11"/>
-    <p:sldId id="261" r:id="rId12"/>
-    <p:sldId id="262" r:id="rId13"/>
-    <p:sldId id="263" r:id="rId14"/>
-    <p:sldId id="264" r:id="rId15"/>
-    <p:sldId id="265" r:id="rId16"/>
-    <p:sldId id="266" r:id="rId17"/>
-    <p:sldId id="267" r:id="rId18"/>
+    <p:sldId id="256" r:id="rId2"/>
+    <p:sldId id="257" r:id="rId3"/>
+    <p:sldId id="258" r:id="rId4"/>
+    <p:sldId id="259" r:id="rId5"/>
+    <p:sldId id="260" r:id="rId6"/>
+    <p:sldId id="261" r:id="rId7"/>
+    <p:sldId id="262" r:id="rId8"/>
+    <p:sldId id="263" r:id="rId9"/>
+    <p:sldId id="264" r:id="rId10"/>
+    <p:sldId id="265" r:id="rId11"/>
+    <p:sldId id="266" r:id="rId12"/>
+    <p:sldId id="267" r:id="rId13"/>
   </p:sldIdLst>
-  <p:sldSz cx="12191695" cy="6858000" type="screen4x3"/>
+  <p:sldSz cx="12192000" cy="6858000"/>
   <p:notesSz cx="6858000" cy="9144000"/>
   <p:defaultTextStyle>
     <a:defPPr>
@@ -115,6 +115,22 @@
       </a:defRPr>
     </a:lvl9pPr>
   </p:defaultTextStyle>
+  <p:extLst>
+    <p:ext uri="{EFAFB233-063F-42B5-8137-9DF3F51BA10A}">
+      <p15:sldGuideLst xmlns:p15="http://schemas.microsoft.com/office/powerpoint/2012/main">
+        <p15:guide id="1" orient="horz" pos="2160">
+          <p15:clr>
+            <a:srgbClr val="A4A3A4"/>
+          </p15:clr>
+        </p15:guide>
+        <p15:guide id="2" pos="2880">
+          <p15:clr>
+            <a:srgbClr val="A4A3A4"/>
+          </p15:clr>
+        </p15:guide>
+      </p15:sldGuideLst>
+    </p:ext>
+  </p:extLst>
 </p:presentation>
 </file>
 
@@ -156,10 +172,9 @@
           <a:lstStyle/>
           <a:p>
             <a:r>
-              <a:rPr lang="en-US" smtClean="0"/>
+              <a:rPr lang="en-US"/>
               <a:t>Click to edit Master title style</a:t>
             </a:r>
-            <a:endParaRPr lang="en-US"/>
           </a:p>
         </p:txBody>
       </p:sp>
@@ -275,10 +290,9 @@
           </a:lstStyle>
           <a:p>
             <a:r>
-              <a:rPr lang="en-US" smtClean="0"/>
+              <a:rPr lang="en-US"/>
               <a:t>Click to edit Master subtitle style</a:t>
             </a:r>
-            <a:endParaRPr lang="en-US"/>
           </a:p>
         </p:txBody>
       </p:sp>
@@ -299,7 +313,7 @@
           <a:p>
             <a:fld id="{5BCAD085-E8A6-8845-BD4E-CB4CCA059FC4}" type="datetimeFigureOut">
               <a:rPr lang="en-US" smtClean="0"/>
-              <a:t>1/27/13</a:t>
+              <a:t>10/23/2026</a:t>
             </a:fld>
             <a:endParaRPr lang="en-US"/>
           </a:p>
@@ -393,10 +407,9 @@
           <a:lstStyle/>
           <a:p>
             <a:r>
-              <a:rPr lang="en-US" smtClean="0"/>
+              <a:rPr lang="en-US"/>
               <a:t>Click to edit Master title style</a:t>
             </a:r>
-            <a:endParaRPr lang="en-US"/>
           </a:p>
         </p:txBody>
       </p:sp>
@@ -417,38 +430,37 @@
           <a:p>
             <a:pPr lvl="0"/>
             <a:r>
-              <a:rPr lang="en-US" smtClean="0"/>
+              <a:rPr lang="en-US"/>
               <a:t>Click to edit Master text styles</a:t>
             </a:r>
           </a:p>
           <a:p>
             <a:pPr lvl="1"/>
             <a:r>
-              <a:rPr lang="en-US" smtClean="0"/>
+              <a:rPr lang="en-US"/>
               <a:t>Second level</a:t>
             </a:r>
           </a:p>
           <a:p>
             <a:pPr lvl="2"/>
             <a:r>
-              <a:rPr lang="en-US" smtClean="0"/>
+              <a:rPr lang="en-US"/>
               <a:t>Third level</a:t>
             </a:r>
           </a:p>
           <a:p>
             <a:pPr lvl="3"/>
             <a:r>
-              <a:rPr lang="en-US" smtClean="0"/>
+              <a:rPr lang="en-US"/>
               <a:t>Fourth level</a:t>
             </a:r>
           </a:p>
           <a:p>
             <a:pPr lvl="4"/>
             <a:r>
-              <a:rPr lang="en-US" smtClean="0"/>
+              <a:rPr lang="en-US"/>
               <a:t>Fifth level</a:t>
             </a:r>
-            <a:endParaRPr lang="en-US"/>
           </a:p>
         </p:txBody>
       </p:sp>
@@ -469,7 +481,7 @@
           <a:p>
             <a:fld id="{5BCAD085-E8A6-8845-BD4E-CB4CCA059FC4}" type="datetimeFigureOut">
               <a:rPr lang="en-US" smtClean="0"/>
-              <a:t>1/27/13</a:t>
+              <a:t>10/23/2026</a:t>
             </a:fld>
             <a:endParaRPr lang="en-US"/>
           </a:p>
@@ -568,10 +580,9 @@
           <a:lstStyle/>
           <a:p>
             <a:r>
-              <a:rPr lang="en-US" smtClean="0"/>
+              <a:rPr lang="en-US"/>
               <a:t>Click to edit Master title style</a:t>
             </a:r>
-            <a:endParaRPr lang="en-US"/>
           </a:p>
         </p:txBody>
       </p:sp>
@@ -597,38 +608,37 @@
           <a:p>
             <a:pPr lvl="0"/>
             <a:r>
-              <a:rPr lang="en-US" smtClean="0"/>
+              <a:rPr lang="en-US"/>
               <a:t>Click to edit Master text styles</a:t>
             </a:r>
           </a:p>
           <a:p>
             <a:pPr lvl="1"/>
             <a:r>
-              <a:rPr lang="en-US" smtClean="0"/>
+              <a:rPr lang="en-US"/>
               <a:t>Second level</a:t>
             </a:r>
           </a:p>
           <a:p>
             <a:pPr lvl="2"/>
             <a:r>
-              <a:rPr lang="en-US" smtClean="0"/>
+              <a:rPr lang="en-US"/>
               <a:t>Third level</a:t>
             </a:r>
           </a:p>
           <a:p>
             <a:pPr lvl="3"/>
             <a:r>
-              <a:rPr lang="en-US" smtClean="0"/>
+              <a:rPr lang="en-US"/>
               <a:t>Fourth level</a:t>
             </a:r>
           </a:p>
           <a:p>
             <a:pPr lvl="4"/>
             <a:r>
-              <a:rPr lang="en-US" smtClean="0"/>
+              <a:rPr lang="en-US"/>
               <a:t>Fifth level</a:t>
             </a:r>
-            <a:endParaRPr lang="en-US"/>
           </a:p>
         </p:txBody>
       </p:sp>
@@ -649,7 +659,7 @@
           <a:p>
             <a:fld id="{5BCAD085-E8A6-8845-BD4E-CB4CCA059FC4}" type="datetimeFigureOut">
               <a:rPr lang="en-US" smtClean="0"/>
-              <a:t>1/27/13</a:t>
+              <a:t>10/23/2026</a:t>
             </a:fld>
             <a:endParaRPr lang="en-US"/>
           </a:p>
@@ -743,10 +753,9 @@
           <a:lstStyle/>
           <a:p>
             <a:r>
-              <a:rPr lang="en-US" smtClean="0"/>
+              <a:rPr lang="en-US"/>
               <a:t>Click to edit Master title style</a:t>
             </a:r>
-            <a:endParaRPr lang="en-US"/>
           </a:p>
         </p:txBody>
       </p:sp>
@@ -767,38 +776,37 @@
           <a:p>
             <a:pPr lvl="0"/>
             <a:r>
-              <a:rPr lang="en-US" smtClean="0"/>
+              <a:rPr lang="en-US"/>
               <a:t>Click to edit Master text styles</a:t>
             </a:r>
           </a:p>
           <a:p>
             <a:pPr lvl="1"/>
             <a:r>
-              <a:rPr lang="en-US" smtClean="0"/>
+              <a:rPr lang="en-US"/>
               <a:t>Second level</a:t>
             </a:r>
           </a:p>
           <a:p>
             <a:pPr lvl="2"/>
             <a:r>
-              <a:rPr lang="en-US" smtClean="0"/>
+              <a:rPr lang="en-US"/>
               <a:t>Third level</a:t>
             </a:r>
           </a:p>
           <a:p>
             <a:pPr lvl="3"/>
             <a:r>
-              <a:rPr lang="en-US" smtClean="0"/>
+              <a:rPr lang="en-US"/>
               <a:t>Fourth level</a:t>
             </a:r>
           </a:p>
           <a:p>
             <a:pPr lvl="4"/>
             <a:r>
-              <a:rPr lang="en-US" smtClean="0"/>
+              <a:rPr lang="en-US"/>
               <a:t>Fifth level</a:t>
             </a:r>
-            <a:endParaRPr lang="en-US"/>
           </a:p>
         </p:txBody>
       </p:sp>
@@ -819,7 +827,7 @@
           <a:p>
             <a:fld id="{5BCAD085-E8A6-8845-BD4E-CB4CCA059FC4}" type="datetimeFigureOut">
               <a:rPr lang="en-US" smtClean="0"/>
-              <a:t>1/27/13</a:t>
+              <a:t>10/23/2026</a:t>
             </a:fld>
             <a:endParaRPr lang="en-US"/>
           </a:p>
@@ -922,10 +930,9 @@
           </a:lstStyle>
           <a:p>
             <a:r>
-              <a:rPr lang="en-US" smtClean="0"/>
+              <a:rPr lang="en-US"/>
               <a:t>Click to edit Master title style</a:t>
             </a:r>
-            <a:endParaRPr lang="en-US"/>
           </a:p>
         </p:txBody>
       </p:sp>
@@ -1042,7 +1049,7 @@
           <a:p>
             <a:pPr lvl="0"/>
             <a:r>
-              <a:rPr lang="en-US" smtClean="0"/>
+              <a:rPr lang="en-US"/>
               <a:t>Click to edit Master text styles</a:t>
             </a:r>
           </a:p>
@@ -1065,7 +1072,7 @@
           <a:p>
             <a:fld id="{5BCAD085-E8A6-8845-BD4E-CB4CCA059FC4}" type="datetimeFigureOut">
               <a:rPr lang="en-US" smtClean="0"/>
-              <a:t>1/27/13</a:t>
+              <a:t>10/23/2026</a:t>
             </a:fld>
             <a:endParaRPr lang="en-US"/>
           </a:p>
@@ -1159,10 +1166,9 @@
           <a:lstStyle/>
           <a:p>
             <a:r>
-              <a:rPr lang="en-US" smtClean="0"/>
+              <a:rPr lang="en-US"/>
               <a:t>Click to edit Master title style</a:t>
             </a:r>
-            <a:endParaRPr lang="en-US"/>
           </a:p>
         </p:txBody>
       </p:sp>
@@ -1216,38 +1222,37 @@
           <a:p>
             <a:pPr lvl="0"/>
             <a:r>
-              <a:rPr lang="en-US" smtClean="0"/>
+              <a:rPr lang="en-US"/>
               <a:t>Click to edit Master text styles</a:t>
             </a:r>
           </a:p>
           <a:p>
             <a:pPr lvl="1"/>
             <a:r>
-              <a:rPr lang="en-US" smtClean="0"/>
+              <a:rPr lang="en-US"/>
               <a:t>Second level</a:t>
             </a:r>
           </a:p>
           <a:p>
             <a:pPr lvl="2"/>
             <a:r>
-              <a:rPr lang="en-US" smtClean="0"/>
+              <a:rPr lang="en-US"/>
               <a:t>Third level</a:t>
             </a:r>
           </a:p>
           <a:p>
             <a:pPr lvl="3"/>
             <a:r>
-              <a:rPr lang="en-US" smtClean="0"/>
+              <a:rPr lang="en-US"/>
               <a:t>Fourth level</a:t>
             </a:r>
           </a:p>
           <a:p>
             <a:pPr lvl="4"/>
             <a:r>
-              <a:rPr lang="en-US" smtClean="0"/>
+              <a:rPr lang="en-US"/>
               <a:t>Fifth level</a:t>
             </a:r>
-            <a:endParaRPr lang="en-US"/>
           </a:p>
         </p:txBody>
       </p:sp>
@@ -1301,38 +1306,37 @@
           <a:p>
             <a:pPr lvl="0"/>
             <a:r>
-              <a:rPr lang="en-US" smtClean="0"/>
+              <a:rPr lang="en-US"/>
               <a:t>Click to edit Master text styles</a:t>
             </a:r>
           </a:p>
           <a:p>
             <a:pPr lvl="1"/>
             <a:r>
-              <a:rPr lang="en-US" smtClean="0"/>
+              <a:rPr lang="en-US"/>
               <a:t>Second level</a:t>
             </a:r>
           </a:p>
           <a:p>
             <a:pPr lvl="2"/>
             <a:r>
-              <a:rPr lang="en-US" smtClean="0"/>
+              <a:rPr lang="en-US"/>
               <a:t>Third level</a:t>
             </a:r>
           </a:p>
           <a:p>
             <a:pPr lvl="3"/>
             <a:r>
-              <a:rPr lang="en-US" smtClean="0"/>
+              <a:rPr lang="en-US"/>
               <a:t>Fourth level</a:t>
             </a:r>
           </a:p>
           <a:p>
             <a:pPr lvl="4"/>
             <a:r>
-              <a:rPr lang="en-US" smtClean="0"/>
+              <a:rPr lang="en-US"/>
               <a:t>Fifth level</a:t>
             </a:r>
-            <a:endParaRPr lang="en-US"/>
           </a:p>
         </p:txBody>
       </p:sp>
@@ -1353,7 +1357,7 @@
           <a:p>
             <a:fld id="{5BCAD085-E8A6-8845-BD4E-CB4CCA059FC4}" type="datetimeFigureOut">
               <a:rPr lang="en-US" smtClean="0"/>
-              <a:t>1/27/13</a:t>
+              <a:t>10/23/2026</a:t>
             </a:fld>
             <a:endParaRPr lang="en-US"/>
           </a:p>
@@ -1451,10 +1455,9 @@
           </a:lstStyle>
           <a:p>
             <a:r>
-              <a:rPr lang="en-US" smtClean="0"/>
+              <a:rPr lang="en-US"/>
               <a:t>Click to edit Master title style</a:t>
             </a:r>
-            <a:endParaRPr lang="en-US"/>
           </a:p>
         </p:txBody>
       </p:sp>
@@ -1517,7 +1520,7 @@
           <a:p>
             <a:pPr lvl="0"/>
             <a:r>
-              <a:rPr lang="en-US" smtClean="0"/>
+              <a:rPr lang="en-US"/>
               <a:t>Click to edit Master text styles</a:t>
             </a:r>
           </a:p>
@@ -1573,38 +1576,37 @@
           <a:p>
             <a:pPr lvl="0"/>
             <a:r>
-              <a:rPr lang="en-US" smtClean="0"/>
+              <a:rPr lang="en-US"/>
               <a:t>Click to edit Master text styles</a:t>
             </a:r>
           </a:p>
           <a:p>
             <a:pPr lvl="1"/>
             <a:r>
-              <a:rPr lang="en-US" smtClean="0"/>
+              <a:rPr lang="en-US"/>
               <a:t>Second level</a:t>
             </a:r>
           </a:p>
           <a:p>
             <a:pPr lvl="2"/>
             <a:r>
-              <a:rPr lang="en-US" smtClean="0"/>
+              <a:rPr lang="en-US"/>
               <a:t>Third level</a:t>
             </a:r>
           </a:p>
           <a:p>
             <a:pPr lvl="3"/>
             <a:r>
-              <a:rPr lang="en-US" smtClean="0"/>
+              <a:rPr lang="en-US"/>
               <a:t>Fourth level</a:t>
             </a:r>
           </a:p>
           <a:p>
             <a:pPr lvl="4"/>
             <a:r>
-              <a:rPr lang="en-US" smtClean="0"/>
+              <a:rPr lang="en-US"/>
               <a:t>Fifth level</a:t>
             </a:r>
-            <a:endParaRPr lang="en-US"/>
           </a:p>
         </p:txBody>
       </p:sp>
@@ -1667,7 +1669,7 @@
           <a:p>
             <a:pPr lvl="0"/>
             <a:r>
-              <a:rPr lang="en-US" smtClean="0"/>
+              <a:rPr lang="en-US"/>
               <a:t>Click to edit Master text styles</a:t>
             </a:r>
           </a:p>
@@ -1723,38 +1725,37 @@
           <a:p>
             <a:pPr lvl="0"/>
             <a:r>
-              <a:rPr lang="en-US" smtClean="0"/>
+              <a:rPr lang="en-US"/>
               <a:t>Click to edit Master text styles</a:t>
             </a:r>
           </a:p>
           <a:p>
             <a:pPr lvl="1"/>
             <a:r>
-              <a:rPr lang="en-US" smtClean="0"/>
+              <a:rPr lang="en-US"/>
               <a:t>Second level</a:t>
             </a:r>
           </a:p>
           <a:p>
             <a:pPr lvl="2"/>
             <a:r>
-              <a:rPr lang="en-US" smtClean="0"/>
+              <a:rPr lang="en-US"/>
               <a:t>Third level</a:t>
             </a:r>
           </a:p>
           <a:p>
             <a:pPr lvl="3"/>
             <a:r>
-              <a:rPr lang="en-US" smtClean="0"/>
+              <a:rPr lang="en-US"/>
               <a:t>Fourth level</a:t>
             </a:r>
           </a:p>
           <a:p>
             <a:pPr lvl="4"/>
             <a:r>
-              <a:rPr lang="en-US" smtClean="0"/>
+              <a:rPr lang="en-US"/>
               <a:t>Fifth level</a:t>
             </a:r>
-            <a:endParaRPr lang="en-US"/>
           </a:p>
         </p:txBody>
       </p:sp>
@@ -1775,7 +1776,7 @@
           <a:p>
             <a:fld id="{5BCAD085-E8A6-8845-BD4E-CB4CCA059FC4}" type="datetimeFigureOut">
               <a:rPr lang="en-US" smtClean="0"/>
-              <a:t>1/27/13</a:t>
+              <a:t>10/23/2026</a:t>
             </a:fld>
             <a:endParaRPr lang="en-US"/>
           </a:p>
@@ -1869,10 +1870,9 @@
           <a:lstStyle/>
           <a:p>
             <a:r>
-              <a:rPr lang="en-US" smtClean="0"/>
+              <a:rPr lang="en-US"/>
               <a:t>Click to edit Master title style</a:t>
             </a:r>
-            <a:endParaRPr lang="en-US"/>
           </a:p>
         </p:txBody>
       </p:sp>
@@ -1893,7 +1893,7 @@
           <a:p>
             <a:fld id="{5BCAD085-E8A6-8845-BD4E-CB4CCA059FC4}" type="datetimeFigureOut">
               <a:rPr lang="en-US" smtClean="0"/>
-              <a:t>1/27/13</a:t>
+              <a:t>10/23/2026</a:t>
             </a:fld>
             <a:endParaRPr lang="en-US"/>
           </a:p>
@@ -1988,7 +1988,7 @@
           <a:p>
             <a:fld id="{5BCAD085-E8A6-8845-BD4E-CB4CCA059FC4}" type="datetimeFigureOut">
               <a:rPr lang="en-US" smtClean="0"/>
-              <a:t>1/27/13</a:t>
+              <a:t>10/23/2026</a:t>
             </a:fld>
             <a:endParaRPr lang="en-US"/>
           </a:p>
@@ -2091,10 +2091,9 @@
           </a:lstStyle>
           <a:p>
             <a:r>
-              <a:rPr lang="en-US" smtClean="0"/>
+              <a:rPr lang="en-US"/>
               <a:t>Click to edit Master title style</a:t>
             </a:r>
-            <a:endParaRPr lang="en-US"/>
           </a:p>
         </p:txBody>
       </p:sp>
@@ -2148,38 +2147,37 @@
           <a:p>
             <a:pPr lvl="0"/>
             <a:r>
-              <a:rPr lang="en-US" smtClean="0"/>
+              <a:rPr lang="en-US"/>
               <a:t>Click to edit Master text styles</a:t>
             </a:r>
           </a:p>
           <a:p>
             <a:pPr lvl="1"/>
             <a:r>
-              <a:rPr lang="en-US" smtClean="0"/>
+              <a:rPr lang="en-US"/>
               <a:t>Second level</a:t>
             </a:r>
           </a:p>
           <a:p>
             <a:pPr lvl="2"/>
             <a:r>
-              <a:rPr lang="en-US" smtClean="0"/>
+              <a:rPr lang="en-US"/>
               <a:t>Third level</a:t>
             </a:r>
           </a:p>
           <a:p>
             <a:pPr lvl="3"/>
             <a:r>
-              <a:rPr lang="en-US" smtClean="0"/>
+              <a:rPr lang="en-US"/>
               <a:t>Fourth level</a:t>
             </a:r>
           </a:p>
           <a:p>
             <a:pPr lvl="4"/>
             <a:r>
-              <a:rPr lang="en-US" smtClean="0"/>
+              <a:rPr lang="en-US"/>
               <a:t>Fifth level</a:t>
             </a:r>
-            <a:endParaRPr lang="en-US"/>
           </a:p>
         </p:txBody>
       </p:sp>
@@ -2242,7 +2240,7 @@
           <a:p>
             <a:pPr lvl="0"/>
             <a:r>
-              <a:rPr lang="en-US" smtClean="0"/>
+              <a:rPr lang="en-US"/>
               <a:t>Click to edit Master text styles</a:t>
             </a:r>
           </a:p>
@@ -2265,7 +2263,7 @@
           <a:p>
             <a:fld id="{5BCAD085-E8A6-8845-BD4E-CB4CCA059FC4}" type="datetimeFigureOut">
               <a:rPr lang="en-US" smtClean="0"/>
-              <a:t>1/27/13</a:t>
+              <a:t>10/23/2026</a:t>
             </a:fld>
             <a:endParaRPr lang="en-US"/>
           </a:p>
@@ -2368,10 +2366,9 @@
           </a:lstStyle>
           <a:p>
             <a:r>
-              <a:rPr lang="en-US" smtClean="0"/>
+              <a:rPr lang="en-US"/>
               <a:t>Click to edit Master title style</a:t>
             </a:r>
-            <a:endParaRPr lang="en-US"/>
           </a:p>
         </p:txBody>
       </p:sp>
@@ -2495,7 +2492,7 @@
           <a:p>
             <a:pPr lvl="0"/>
             <a:r>
-              <a:rPr lang="en-US" smtClean="0"/>
+              <a:rPr lang="en-US"/>
               <a:t>Click to edit Master text styles</a:t>
             </a:r>
           </a:p>
@@ -2518,7 +2515,7 @@
           <a:p>
             <a:fld id="{5BCAD085-E8A6-8845-BD4E-CB4CCA059FC4}" type="datetimeFigureOut">
               <a:rPr lang="en-US" smtClean="0"/>
-              <a:t>1/27/13</a:t>
+              <a:t>10/23/2026</a:t>
             </a:fld>
             <a:endParaRPr lang="en-US"/>
           </a:p>
@@ -2627,10 +2624,9 @@
           <a:lstStyle/>
           <a:p>
             <a:r>
-              <a:rPr lang="en-US" smtClean="0"/>
+              <a:rPr lang="en-US"/>
               <a:t>Click to edit Master title style</a:t>
             </a:r>
-            <a:endParaRPr lang="en-US"/>
           </a:p>
         </p:txBody>
       </p:sp>
@@ -2661,38 +2657,37 @@
           <a:p>
             <a:pPr lvl="0"/>
             <a:r>
-              <a:rPr lang="en-US" smtClean="0"/>
+              <a:rPr lang="en-US"/>
               <a:t>Click to edit Master text styles</a:t>
             </a:r>
           </a:p>
           <a:p>
             <a:pPr lvl="1"/>
             <a:r>
-              <a:rPr lang="en-US" smtClean="0"/>
+              <a:rPr lang="en-US"/>
               <a:t>Second level</a:t>
             </a:r>
           </a:p>
           <a:p>
             <a:pPr lvl="2"/>
             <a:r>
-              <a:rPr lang="en-US" smtClean="0"/>
+              <a:rPr lang="en-US"/>
               <a:t>Third level</a:t>
             </a:r>
           </a:p>
           <a:p>
             <a:pPr lvl="3"/>
             <a:r>
-              <a:rPr lang="en-US" smtClean="0"/>
+              <a:rPr lang="en-US"/>
               <a:t>Fourth level</a:t>
             </a:r>
           </a:p>
           <a:p>
             <a:pPr lvl="4"/>
             <a:r>
-              <a:rPr lang="en-US" smtClean="0"/>
+              <a:rPr lang="en-US"/>
               <a:t>Fifth level</a:t>
             </a:r>
-            <a:endParaRPr lang="en-US"/>
           </a:p>
         </p:txBody>
       </p:sp>
@@ -2731,7 +2726,7 @@
           <a:p>
             <a:fld id="{5BCAD085-E8A6-8845-BD4E-CB4CCA059FC4}" type="datetimeFigureOut">
               <a:rPr lang="en-US" smtClean="0"/>
-              <a:t>1/27/13</a:t>
+              <a:t>10/23/2026</a:t>
             </a:fld>
             <a:endParaRPr lang="en-US"/>
           </a:p>
@@ -3090,7 +3085,7 @@
 </file>
 
 <file path=ppt/slides/slide1.xml><?xml version="1.0" encoding="utf-8"?>
-<p:sld xmlns:a="http://schemas.openxmlformats.org/drawingml/2006/main" xmlns:p="http://schemas.openxmlformats.org/presentationml/2006/main" xmlns:r="http://schemas.openxmlformats.org/officeDocument/2006/relationships">
+<p:sld xmlns:a="http://schemas.openxmlformats.org/drawingml/2006/main" xmlns:r="http://schemas.openxmlformats.org/officeDocument/2006/relationships" xmlns:p="http://schemas.openxmlformats.org/presentationml/2006/main">
   <p:cSld>
     <p:spTree>
       <p:nvGrpSpPr>
@@ -3098,7 +3093,14 @@
         <p:cNvGrpSpPr/>
         <p:nvPr/>
       </p:nvGrpSpPr>
-      <p:grpSpPr/>
+      <p:grpSpPr>
+        <a:xfrm>
+          <a:off x="0" y="0"/>
+          <a:ext cx="0" cy="0"/>
+          <a:chOff x="0" y="0"/>
+          <a:chExt cx="0" cy="0"/>
+        </a:xfrm>
+      </p:grpSpPr>
       <p:sp>
         <p:nvSpPr>
           <p:cNvPr id="2" name="Rectangle 1"/>
@@ -3141,6 +3143,7 @@
           <a:lstStyle/>
           <a:p>
             <a:pPr algn="ctr"/>
+            <a:endParaRPr/>
           </a:p>
         </p:txBody>
       </p:sp>
@@ -3182,7 +3185,7 @@
           </a:fontRef>
         </p:style>
         <p:txBody>
-          <a:bodyPr rtlCol="0" anchor="ctr" wrap="square"/>
+          <a:bodyPr wrap="square" rtlCol="0" anchor="ctr"/>
           <a:lstStyle/>
           <a:p>
             <a:pPr algn="ctr">
@@ -3298,11 +3301,23 @@
               </a:defRPr>
             </a:pPr>
             <a:r>
+              <a:rPr dirty="0"/>
               <a:t>Complete Chapter-Wise Visual Engineering Guide based on SHAKTI User Manual V1.3.1</a:t>
             </a:r>
-            <a:br/>
-            <a:r>
-              <a:t>RISE Lab, IIT Madras • Swadeshi Microprocessor Challenge (MeitY)</a:t>
+            <a:br>
+              <a:rPr dirty="0"/>
+            </a:br>
+            <a:r>
+              <a:rPr dirty="0"/>
+              <a:t>RISE Lab, IIT Madras • Swadeshi Microprocessor Challenge (</a:t>
+            </a:r>
+            <a:r>
+              <a:rPr dirty="0" err="1"/>
+              <a:t>MeitY</a:t>
+            </a:r>
+            <a:r>
+              <a:rPr dirty="0"/>
+              <a:t>)</a:t>
             </a:r>
           </a:p>
         </p:txBody>
@@ -3345,7 +3360,7 @@
           </a:fontRef>
         </p:style>
         <p:txBody>
-          <a:bodyPr rtlCol="0" anchor="ctr" wrap="square"/>
+          <a:bodyPr wrap="square" rtlCol="0" anchor="ctr"/>
           <a:lstStyle/>
           <a:p>
             <a:pPr algn="ctr">
@@ -3356,20 +3371,41 @@
               </a:defRPr>
             </a:pPr>
             <a:r>
-              <a:t>🇮🇳 Swadeshi Initiative</a:t>
-            </a:r>
-          </a:p>
-          <a:p>
-            <a:br/>
-            <a:pPr>
-              <a:defRPr sz="1100">
-                <a:solidFill>
-                  <a:srgbClr val="334155"/>
-                </a:solidFill>
-              </a:defRPr>
-            </a:pPr>
-            <a:r>
-              <a:t>Indigenous open-source production-grade processors developed at IIT Madras, funded by MeitY to create sovereign silicon solutions.</a:t>
+              <a:rPr lang="en-US" dirty="0"/>
+              <a:t>S</a:t>
+            </a:r>
+            <a:r>
+              <a:rPr dirty="0"/>
+              <a:t>wadeshi Initiative</a:t>
+            </a:r>
+          </a:p>
+          <a:p>
+            <a:br>
+              <a:rPr dirty="0"/>
+            </a:br>
+            <a:r>
+              <a:rPr dirty="0">
+                <a:solidFill>
+                  <a:schemeClr val="tx1"/>
+                </a:solidFill>
+              </a:rPr>
+              <a:t>Indigenous open-source production-grade processors developed at IIT Madras, funded by </a:t>
+            </a:r>
+            <a:r>
+              <a:rPr dirty="0" err="1">
+                <a:solidFill>
+                  <a:schemeClr val="tx1"/>
+                </a:solidFill>
+              </a:rPr>
+              <a:t>MeitY</a:t>
+            </a:r>
+            <a:r>
+              <a:rPr dirty="0">
+                <a:solidFill>
+                  <a:schemeClr val="tx1"/>
+                </a:solidFill>
+              </a:rPr>
+              <a:t> to create sovereign silicon solutions.</a:t>
             </a:r>
           </a:p>
         </p:txBody>
@@ -3412,7 +3448,7 @@
           </a:fontRef>
         </p:style>
         <p:txBody>
-          <a:bodyPr rtlCol="0" anchor="ctr" wrap="square"/>
+          <a:bodyPr wrap="square" rtlCol="0" anchor="ctr"/>
           <a:lstStyle/>
           <a:p>
             <a:pPr algn="ctr">
@@ -3423,19 +3459,20 @@
               </a:defRPr>
             </a:pPr>
             <a:r>
-              <a:t>🧩 6 Processor Classes</a:t>
-            </a:r>
-          </a:p>
-          <a:p>
-            <a:br/>
-            <a:pPr>
-              <a:defRPr sz="1100">
-                <a:solidFill>
-                  <a:srgbClr val="334155"/>
-                </a:solidFill>
-              </a:defRPr>
-            </a:pPr>
-            <a:r>
+              <a:rPr dirty="0"/>
+              <a:t>6 Processor Classes</a:t>
+            </a:r>
+          </a:p>
+          <a:p>
+            <a:br>
+              <a:rPr dirty="0"/>
+            </a:br>
+            <a:r>
+              <a:rPr dirty="0">
+                <a:solidFill>
+                  <a:schemeClr val="tx1"/>
+                </a:solidFill>
+              </a:rPr>
               <a:t>Full RISC-V roadmap spanning from ultra-low power 32-bit microcontrollers (E-Class) to 64-bit multi-core servers (C-Class &amp; I-Class).</a:t>
             </a:r>
           </a:p>
@@ -3479,7 +3516,7 @@
           </a:fontRef>
         </p:style>
         <p:txBody>
-          <a:bodyPr rtlCol="0" anchor="ctr" wrap="square"/>
+          <a:bodyPr wrap="square" rtlCol="0" anchor="ctr"/>
           <a:lstStyle/>
           <a:p>
             <a:pPr algn="ctr">
@@ -3490,20 +3527,101 @@
               </a:defRPr>
             </a:pPr>
             <a:r>
+              <a:rPr dirty="0"/>
               <a:t>⚡ Complete Ecosystem</a:t>
             </a:r>
           </a:p>
           <a:p>
-            <a:br/>
-            <a:pPr>
-              <a:defRPr sz="1100">
-                <a:solidFill>
-                  <a:srgbClr val="334155"/>
-                </a:solidFill>
-              </a:defRPr>
-            </a:pPr>
-            <a:r>
-              <a:t>Full ecosystem: Bluespec SystemVerilog (BSV) RTL, Vivado bitstreams, Board Support Packages (BSP), FreeRTOS, and OpenOCD GDB debugging.</a:t>
+            <a:br>
+              <a:rPr dirty="0"/>
+            </a:br>
+            <a:r>
+              <a:rPr dirty="0">
+                <a:solidFill>
+                  <a:schemeClr val="tx1"/>
+                </a:solidFill>
+              </a:rPr>
+              <a:t>Full ecosystem: </a:t>
+            </a:r>
+            <a:r>
+              <a:rPr dirty="0" err="1">
+                <a:solidFill>
+                  <a:schemeClr val="tx1"/>
+                </a:solidFill>
+              </a:rPr>
+              <a:t>Bluespec</a:t>
+            </a:r>
+            <a:r>
+              <a:rPr dirty="0">
+                <a:solidFill>
+                  <a:schemeClr val="tx1"/>
+                </a:solidFill>
+              </a:rPr>
+              <a:t> </a:t>
+            </a:r>
+            <a:r>
+              <a:rPr dirty="0" err="1">
+                <a:solidFill>
+                  <a:schemeClr val="tx1"/>
+                </a:solidFill>
+              </a:rPr>
+              <a:t>SystemVerilog</a:t>
+            </a:r>
+            <a:r>
+              <a:rPr dirty="0">
+                <a:solidFill>
+                  <a:schemeClr val="tx1"/>
+                </a:solidFill>
+              </a:rPr>
+              <a:t> (BSV) RTL, </a:t>
+            </a:r>
+            <a:r>
+              <a:rPr dirty="0" err="1">
+                <a:solidFill>
+                  <a:schemeClr val="tx1"/>
+                </a:solidFill>
+              </a:rPr>
+              <a:t>Vivado</a:t>
+            </a:r>
+            <a:r>
+              <a:rPr dirty="0">
+                <a:solidFill>
+                  <a:schemeClr val="tx1"/>
+                </a:solidFill>
+              </a:rPr>
+              <a:t> bitstreams, Board Support Packages (BSP), </a:t>
+            </a:r>
+            <a:r>
+              <a:rPr dirty="0" err="1">
+                <a:solidFill>
+                  <a:schemeClr val="tx1"/>
+                </a:solidFill>
+              </a:rPr>
+              <a:t>FreeRTOS</a:t>
+            </a:r>
+            <a:r>
+              <a:rPr dirty="0">
+                <a:solidFill>
+                  <a:schemeClr val="tx1"/>
+                </a:solidFill>
+              </a:rPr>
+              <a:t>, and </a:t>
+            </a:r>
+            <a:r>
+              <a:rPr dirty="0" err="1">
+                <a:solidFill>
+                  <a:schemeClr val="tx1"/>
+                </a:solidFill>
+              </a:rPr>
+              <a:t>OpenOCD</a:t>
+            </a:r>
+            <a:r>
+              <a:rPr dirty="0">
+                <a:solidFill>
+                  <a:schemeClr val="tx1"/>
+                </a:solidFill>
+              </a:rPr>
+              <a:t> GDB debugging.</a:t>
             </a:r>
           </a:p>
         </p:txBody>
@@ -3516,8 +3634,8 @@
         </p:nvSpPr>
         <p:spPr>
           <a:xfrm>
-            <a:off x="731520" y="6309360"/>
-            <a:ext cx="10698480" cy="320040"/>
+            <a:off x="447435" y="6405372"/>
+            <a:ext cx="3363421" cy="230832"/>
           </a:xfrm>
           <a:prstGeom prst="rect">
             <a:avLst/>
@@ -3538,6 +3656,7 @@
               </a:defRPr>
             </a:pPr>
             <a:r>
+              <a:rPr dirty="0"/>
               <a:t>SHAKTI User Manual v1.3.1 (RISE Lab, IIT Madras)  •  Module 1 of 12</a:t>
             </a:r>
           </a:p>
@@ -3552,7 +3671,7 @@
 </file>
 
 <file path=ppt/slides/slide10.xml><?xml version="1.0" encoding="utf-8"?>
-<p:sld xmlns:a="http://schemas.openxmlformats.org/drawingml/2006/main" xmlns:p="http://schemas.openxmlformats.org/presentationml/2006/main" xmlns:r="http://schemas.openxmlformats.org/officeDocument/2006/relationships">
+<p:sld xmlns:a="http://schemas.openxmlformats.org/drawingml/2006/main" xmlns:r="http://schemas.openxmlformats.org/officeDocument/2006/relationships" xmlns:p="http://schemas.openxmlformats.org/presentationml/2006/main">
   <p:cSld>
     <p:spTree>
       <p:nvGrpSpPr>
@@ -3560,7 +3679,14 @@
         <p:cNvGrpSpPr/>
         <p:nvPr/>
       </p:nvGrpSpPr>
-      <p:grpSpPr/>
+      <p:grpSpPr>
+        <a:xfrm>
+          <a:off x="0" y="0"/>
+          <a:ext cx="0" cy="0"/>
+          <a:chOff x="0" y="0"/>
+          <a:chExt cx="0" cy="0"/>
+        </a:xfrm>
+      </p:grpSpPr>
       <p:sp>
         <p:nvSpPr>
           <p:cNvPr id="2" name="Rectangle 1"/>
@@ -3603,6 +3729,7 @@
           <a:lstStyle/>
           <a:p>
             <a:pPr algn="ctr"/>
+            <a:endParaRPr/>
           </a:p>
         </p:txBody>
       </p:sp>
@@ -3644,7 +3771,7 @@
           </a:fontRef>
         </p:style>
         <p:txBody>
-          <a:bodyPr rtlCol="0" anchor="ctr" wrap="square"/>
+          <a:bodyPr wrap="square" rtlCol="0" anchor="ctr"/>
           <a:lstStyle/>
           <a:p>
             <a:pPr algn="ctr">
@@ -3803,7 +3930,7 @@
           </a:fontRef>
         </p:style>
         <p:txBody>
-          <a:bodyPr rtlCol="0" anchor="ctr" wrap="square"/>
+          <a:bodyPr wrap="square" rtlCol="0" anchor="ctr"/>
           <a:lstStyle/>
           <a:p>
             <a:pPr algn="ctr">
@@ -3849,6 +3976,7 @@
                 </a:solidFill>
               </a:defRPr>
             </a:pPr>
+            <a:endParaRPr/>
           </a:p>
           <a:p>
             <a:pPr>
@@ -3950,7 +4078,7 @@
           </a:fontRef>
         </p:style>
         <p:txBody>
-          <a:bodyPr rtlCol="0" anchor="ctr" wrap="square"/>
+          <a:bodyPr wrap="square" rtlCol="0" anchor="ctr"/>
           <a:lstStyle/>
           <a:p>
             <a:pPr algn="ctr">
@@ -4008,6 +4136,7 @@
                 </a:solidFill>
               </a:defRPr>
             </a:pPr>
+            <a:endParaRPr/>
           </a:p>
           <a:p>
             <a:pPr>
@@ -4109,7 +4238,7 @@
           </a:fontRef>
         </p:style>
         <p:txBody>
-          <a:bodyPr rtlCol="0" anchor="ctr" wrap="square"/>
+          <a:bodyPr wrap="square" rtlCol="0" anchor="ctr"/>
           <a:lstStyle/>
           <a:p>
             <a:pPr algn="ctr">
@@ -4155,6 +4284,7 @@
                 </a:solidFill>
               </a:defRPr>
             </a:pPr>
+            <a:endParaRPr/>
           </a:p>
           <a:p>
             <a:pPr>
@@ -4262,7 +4392,7 @@
 </file>
 
 <file path=ppt/slides/slide11.xml><?xml version="1.0" encoding="utf-8"?>
-<p:sld xmlns:a="http://schemas.openxmlformats.org/drawingml/2006/main" xmlns:p="http://schemas.openxmlformats.org/presentationml/2006/main" xmlns:r="http://schemas.openxmlformats.org/officeDocument/2006/relationships">
+<p:sld xmlns:a="http://schemas.openxmlformats.org/drawingml/2006/main" xmlns:r="http://schemas.openxmlformats.org/officeDocument/2006/relationships" xmlns:p="http://schemas.openxmlformats.org/presentationml/2006/main">
   <p:cSld>
     <p:spTree>
       <p:nvGrpSpPr>
@@ -4270,7 +4400,14 @@
         <p:cNvGrpSpPr/>
         <p:nvPr/>
       </p:nvGrpSpPr>
-      <p:grpSpPr/>
+      <p:grpSpPr>
+        <a:xfrm>
+          <a:off x="0" y="0"/>
+          <a:ext cx="0" cy="0"/>
+          <a:chOff x="0" y="0"/>
+          <a:chExt cx="0" cy="0"/>
+        </a:xfrm>
+      </p:grpSpPr>
       <p:sp>
         <p:nvSpPr>
           <p:cNvPr id="2" name="Rectangle 1"/>
@@ -4313,6 +4450,7 @@
           <a:lstStyle/>
           <a:p>
             <a:pPr algn="ctr"/>
+            <a:endParaRPr/>
           </a:p>
         </p:txBody>
       </p:sp>
@@ -4354,7 +4492,7 @@
           </a:fontRef>
         </p:style>
         <p:txBody>
-          <a:bodyPr rtlCol="0" anchor="ctr" wrap="square"/>
+          <a:bodyPr wrap="square" rtlCol="0" anchor="ctr"/>
           <a:lstStyle/>
           <a:p>
             <a:pPr algn="ctr">
@@ -4513,7 +4651,7 @@
           </a:fontRef>
         </p:style>
         <p:txBody>
-          <a:bodyPr rtlCol="0" anchor="ctr" wrap="square"/>
+          <a:bodyPr wrap="square" rtlCol="0" anchor="ctr"/>
           <a:lstStyle/>
           <a:p>
             <a:pPr algn="ctr">
@@ -4529,13 +4667,6 @@
           </a:p>
           <a:p>
             <a:br/>
-            <a:pPr>
-              <a:defRPr sz="1050" b="1">
-                <a:solidFill>
-                  <a:srgbClr val="0F172A"/>
-                </a:solidFill>
-              </a:defRPr>
-            </a:pPr>
             <a:r>
               <a:t>📌 Debug Mode (Development)</a:t>
             </a:r>
@@ -4554,13 +4685,6 @@
           </a:p>
           <a:p>
             <a:br/>
-            <a:pPr>
-              <a:defRPr sz="1050" b="1">
-                <a:solidFill>
-                  <a:srgbClr val="0F172A"/>
-                </a:solidFill>
-              </a:defRPr>
-            </a:pPr>
             <a:r>
               <a:t>📌 Standalone Mode (Production)</a:t>
             </a:r>
@@ -4617,7 +4741,7 @@
           </a:fontRef>
         </p:style>
         <p:txBody>
-          <a:bodyPr rtlCol="0" anchor="ctr" wrap="square"/>
+          <a:bodyPr wrap="square" rtlCol="0" anchor="ctr"/>
           <a:lstStyle/>
           <a:p>
             <a:pPr algn="ctr">
@@ -4675,6 +4799,7 @@
                 </a:solidFill>
               </a:defRPr>
             </a:pPr>
+            <a:endParaRPr/>
           </a:p>
           <a:p>
             <a:pPr>
@@ -4794,7 +4919,7 @@
 </file>
 
 <file path=ppt/slides/slide12.xml><?xml version="1.0" encoding="utf-8"?>
-<p:sld xmlns:a="http://schemas.openxmlformats.org/drawingml/2006/main" xmlns:p="http://schemas.openxmlformats.org/presentationml/2006/main" xmlns:r="http://schemas.openxmlformats.org/officeDocument/2006/relationships">
+<p:sld xmlns:a="http://schemas.openxmlformats.org/drawingml/2006/main" xmlns:r="http://schemas.openxmlformats.org/officeDocument/2006/relationships" xmlns:p="http://schemas.openxmlformats.org/presentationml/2006/main">
   <p:cSld>
     <p:spTree>
       <p:nvGrpSpPr>
@@ -4802,7 +4927,14 @@
         <p:cNvGrpSpPr/>
         <p:nvPr/>
       </p:nvGrpSpPr>
-      <p:grpSpPr/>
+      <p:grpSpPr>
+        <a:xfrm>
+          <a:off x="0" y="0"/>
+          <a:ext cx="0" cy="0"/>
+          <a:chOff x="0" y="0"/>
+          <a:chExt cx="0" cy="0"/>
+        </a:xfrm>
+      </p:grpSpPr>
       <p:sp>
         <p:nvSpPr>
           <p:cNvPr id="2" name="Rectangle 1"/>
@@ -4845,6 +4977,7 @@
           <a:lstStyle/>
           <a:p>
             <a:pPr algn="ctr"/>
+            <a:endParaRPr/>
           </a:p>
         </p:txBody>
       </p:sp>
@@ -4886,7 +5019,7 @@
           </a:fontRef>
         </p:style>
         <p:txBody>
-          <a:bodyPr rtlCol="0" anchor="ctr" wrap="square"/>
+          <a:bodyPr wrap="square" rtlCol="0" anchor="ctr"/>
           <a:lstStyle/>
           <a:p>
             <a:pPr algn="ctr">
@@ -5045,7 +5178,7 @@
           </a:fontRef>
         </p:style>
         <p:txBody>
-          <a:bodyPr rtlCol="0" anchor="ctr" wrap="square"/>
+          <a:bodyPr wrap="square" rtlCol="0" anchor="ctr"/>
           <a:lstStyle/>
           <a:p>
             <a:pPr algn="ctr">
@@ -5061,13 +5194,6 @@
           </a:p>
           <a:p>
             <a:br/>
-            <a:pPr>
-              <a:defRPr sz="1000" b="1">
-                <a:solidFill>
-                  <a:srgbClr val="0F172A"/>
-                </a:solidFill>
-              </a:defRPr>
-            </a:pPr>
             <a:r>
               <a:t>⚡ Bits = 00 (Default)</a:t>
             </a:r>
@@ -5086,13 +5212,6 @@
           </a:p>
           <a:p>
             <a:br/>
-            <a:pPr>
-              <a:defRPr sz="1000" b="1">
-                <a:solidFill>
-                  <a:srgbClr val="0F172A"/>
-                </a:solidFill>
-              </a:defRPr>
-            </a:pPr>
             <a:r>
               <a:t>⚡ Bits = 01 (Serial / SPI)</a:t>
             </a:r>
@@ -5111,13 +5230,6 @@
           </a:p>
           <a:p>
             <a:br/>
-            <a:pPr>
-              <a:defRPr sz="1000" b="1">
-                <a:solidFill>
-                  <a:srgbClr val="0F172A"/>
-                </a:solidFill>
-              </a:defRPr>
-            </a:pPr>
             <a:r>
               <a:t>⚡ Bits = 10 (PWM Mode)</a:t>
             </a:r>
@@ -5136,13 +5248,6 @@
           </a:p>
           <a:p>
             <a:br/>
-            <a:pPr>
-              <a:defRPr sz="1000" b="1">
-                <a:solidFill>
-                  <a:srgbClr val="0F172A"/>
-                </a:solidFill>
-              </a:defRPr>
-            </a:pPr>
             <a:r>
               <a:t>⚡ Bits = 11 (Reserved)</a:t>
             </a:r>
@@ -5199,7 +5304,7 @@
           </a:fontRef>
         </p:style>
         <p:txBody>
-          <a:bodyPr rtlCol="0" anchor="ctr" wrap="square"/>
+          <a:bodyPr wrap="square" rtlCol="0" anchor="ctr"/>
           <a:lstStyle/>
           <a:p>
             <a:pPr algn="ctr">
@@ -5245,6 +5350,7 @@
                 </a:solidFill>
               </a:defRPr>
             </a:pPr>
+            <a:endParaRPr/>
           </a:p>
           <a:p>
             <a:pPr>
@@ -5278,6 +5384,7 @@
                 </a:solidFill>
               </a:defRPr>
             </a:pPr>
+            <a:endParaRPr/>
           </a:p>
           <a:p>
             <a:pPr>
@@ -5323,6 +5430,7 @@
                 </a:solidFill>
               </a:defRPr>
             </a:pPr>
+            <a:endParaRPr/>
           </a:p>
           <a:p>
             <a:pPr>
@@ -5368,6 +5476,7 @@
                 </a:solidFill>
               </a:defRPr>
             </a:pPr>
+            <a:endParaRPr/>
           </a:p>
           <a:p>
             <a:pPr>
@@ -5439,7 +5548,7 @@
 </file>
 
 <file path=ppt/slides/slide2.xml><?xml version="1.0" encoding="utf-8"?>
-<p:sld xmlns:a="http://schemas.openxmlformats.org/drawingml/2006/main" xmlns:p="http://schemas.openxmlformats.org/presentationml/2006/main" xmlns:r="http://schemas.openxmlformats.org/officeDocument/2006/relationships">
+<p:sld xmlns:a="http://schemas.openxmlformats.org/drawingml/2006/main" xmlns:r="http://schemas.openxmlformats.org/officeDocument/2006/relationships" xmlns:p="http://schemas.openxmlformats.org/presentationml/2006/main">
   <p:cSld>
     <p:spTree>
       <p:nvGrpSpPr>
@@ -5447,7 +5556,14 @@
         <p:cNvGrpSpPr/>
         <p:nvPr/>
       </p:nvGrpSpPr>
-      <p:grpSpPr/>
+      <p:grpSpPr>
+        <a:xfrm>
+          <a:off x="0" y="0"/>
+          <a:ext cx="0" cy="0"/>
+          <a:chOff x="0" y="0"/>
+          <a:chExt cx="0" cy="0"/>
+        </a:xfrm>
+      </p:grpSpPr>
       <p:sp>
         <p:nvSpPr>
           <p:cNvPr id="2" name="Rectangle 1"/>
@@ -5490,6 +5606,7 @@
           <a:lstStyle/>
           <a:p>
             <a:pPr algn="ctr"/>
+            <a:endParaRPr/>
           </a:p>
         </p:txBody>
       </p:sp>
@@ -5531,7 +5648,7 @@
           </a:fontRef>
         </p:style>
         <p:txBody>
-          <a:bodyPr rtlCol="0" anchor="ctr" wrap="square"/>
+          <a:bodyPr wrap="square" rtlCol="0" anchor="ctr"/>
           <a:lstStyle/>
           <a:p>
             <a:pPr algn="ctr">
@@ -5612,6 +5729,7 @@
               </a:defRPr>
             </a:pPr>
             <a:r>
+              <a:rPr dirty="0"/>
               <a:t>E-Class: Embedded &amp; IoT Microcontroller Core</a:t>
             </a:r>
           </a:p>
@@ -5647,6 +5765,7 @@
               </a:defRPr>
             </a:pPr>
             <a:r>
+              <a:rPr dirty="0"/>
               <a:t>Positioned against ARM Cortex-M series for low-power compute, automotive sensors, and smart meters.</a:t>
             </a:r>
           </a:p>
@@ -5690,7 +5809,7 @@
           </a:fontRef>
         </p:style>
         <p:txBody>
-          <a:bodyPr rtlCol="0" anchor="ctr" wrap="square"/>
+          <a:bodyPr wrap="square" rtlCol="0" anchor="ctr"/>
           <a:lstStyle/>
           <a:p>
             <a:pPr algn="ctr">
@@ -5701,6 +5820,7 @@
               </a:defRPr>
             </a:pPr>
             <a:r>
+              <a:rPr dirty="0"/>
               <a:t>MICROARCHITECTURE SPECIFICATIONS</a:t>
             </a:r>
           </a:p>
@@ -5713,6 +5833,7 @@
               </a:defRPr>
             </a:pPr>
             <a:r>
+              <a:rPr dirty="0"/>
               <a:t>• Architecture: 32-bit RISC-V In-Order pipeline</a:t>
             </a:r>
           </a:p>
@@ -5725,6 +5846,7 @@
               </a:defRPr>
             </a:pPr>
             <a:r>
+              <a:rPr dirty="0"/>
               <a:t>• Pipeline Depth: 3-Stage (Fetch → Decode/Execute → Writeback)</a:t>
             </a:r>
           </a:p>
@@ -5737,6 +5859,7 @@
               </a:defRPr>
             </a:pPr>
             <a:r>
+              <a:rPr dirty="0"/>
               <a:t>• Operating Frequency: &lt; 200 MHz on ASIC silicon; 50 MHz on Artix-7 FPGA</a:t>
             </a:r>
           </a:p>
@@ -5749,7 +5872,24 @@
               </a:defRPr>
             </a:pPr>
             <a:r>
-              <a:t>• ISA Support: RV32IMAC (Base Integer, Mul/Div, Atomic, Compressed)</a:t>
+              <a:rPr dirty="0"/>
+              <a:t>• ISA Support: RV32IMAC (Base Integer, </a:t>
+            </a:r>
+            <a:r>
+              <a:rPr dirty="0" err="1"/>
+              <a:t>Mul</a:t>
+            </a:r>
+            <a:r>
+              <a:rPr dirty="0"/>
+              <a:t>/</a:t>
+            </a:r>
+            <a:r>
+              <a:rPr dirty="0" err="1"/>
+              <a:t>Div</a:t>
+            </a:r>
+            <a:r>
+              <a:rPr dirty="0"/>
+              <a:t>, Atomic, Compressed)</a:t>
             </a:r>
           </a:p>
           <a:p>
@@ -5761,6 +5901,7 @@
               </a:defRPr>
             </a:pPr>
             <a:r>
+              <a:rPr dirty="0"/>
               <a:t>• Privilege Modes: Machine (M) mode and optional User (U) mode</a:t>
             </a:r>
           </a:p>
@@ -5773,6 +5914,7 @@
               </a:defRPr>
             </a:pPr>
             <a:r>
+              <a:rPr dirty="0"/>
               <a:t>• Physical Protection: PMP (Physical Memory Protection) enabled</a:t>
             </a:r>
           </a:p>
@@ -5785,6 +5927,7 @@
               </a:defRPr>
             </a:pPr>
             <a:r>
+              <a:rPr dirty="0"/>
               <a:t>• Target Workloads: Motor control, IoT sensor nodes, smart cards, automation</a:t>
             </a:r>
           </a:p>
@@ -5828,7 +5971,7 @@
           </a:fontRef>
         </p:style>
         <p:txBody>
-          <a:bodyPr rtlCol="0" anchor="ctr" wrap="square"/>
+          <a:bodyPr wrap="square" rtlCol="0" anchor="ctr"/>
           <a:lstStyle/>
           <a:p>
             <a:pPr algn="ctr">
@@ -5839,19 +5982,16 @@
               </a:defRPr>
             </a:pPr>
             <a:r>
+              <a:rPr dirty="0"/>
               <a:t>3-STAGE IN-ORDER PIPELINE FLOW</a:t>
             </a:r>
           </a:p>
           <a:p>
-            <a:br/>
-            <a:pPr>
-              <a:defRPr sz="1100" b="1">
-                <a:solidFill>
-                  <a:srgbClr val="0F172A"/>
-                </a:solidFill>
-              </a:defRPr>
-            </a:pPr>
-            <a:r>
+            <a:br>
+              <a:rPr dirty="0"/>
+            </a:br>
+            <a:r>
+              <a:rPr dirty="0"/>
               <a:t>📌 Stage 1: Instruction Fetch (IF)</a:t>
             </a:r>
           </a:p>
@@ -5864,19 +6004,16 @@
               </a:defRPr>
             </a:pPr>
             <a:r>
+              <a:rPr dirty="0"/>
               <a:t>Program counter generation, Instruction cache lookup or BRAM memory access, 16-bit compressed instruction decompressor.</a:t>
             </a:r>
           </a:p>
           <a:p>
-            <a:br/>
-            <a:pPr>
-              <a:defRPr sz="1100" b="1">
-                <a:solidFill>
-                  <a:srgbClr val="0F172A"/>
-                </a:solidFill>
-              </a:defRPr>
-            </a:pPr>
-            <a:r>
+            <a:br>
+              <a:rPr dirty="0"/>
+            </a:br>
+            <a:r>
+              <a:rPr dirty="0"/>
               <a:t>📌 Stage 2: Decode &amp; Execute (ID / EX)</a:t>
             </a:r>
           </a:p>
@@ -5889,19 +6026,16 @@
               </a:defRPr>
             </a:pPr>
             <a:r>
+              <a:rPr dirty="0"/>
               <a:t>Instruction decoding, Register file operand read, Integer ALU arithmetic/logic, Branch resolution, Multi-cycle pipelined multiplier/divider.</a:t>
             </a:r>
           </a:p>
           <a:p>
-            <a:br/>
-            <a:pPr>
-              <a:defRPr sz="1100" b="1">
-                <a:solidFill>
-                  <a:srgbClr val="0F172A"/>
-                </a:solidFill>
-              </a:defRPr>
-            </a:pPr>
-            <a:r>
+            <a:br>
+              <a:rPr dirty="0"/>
+            </a:br>
+            <a:r>
+              <a:rPr dirty="0"/>
               <a:t>📌 Stage 3: Memory &amp; Writeback (MEM / WB)</a:t>
             </a:r>
           </a:p>
@@ -5914,6 +6048,7 @@
               </a:defRPr>
             </a:pPr>
             <a:r>
+              <a:rPr dirty="0"/>
               <a:t>Data cache / peripheral MMIO read/write access, Register file commit, CSR updates, Exception &amp; Interrupt handling.</a:t>
             </a:r>
           </a:p>
@@ -5963,7 +6098,7 @@
 </file>
 
 <file path=ppt/slides/slide3.xml><?xml version="1.0" encoding="utf-8"?>
-<p:sld xmlns:a="http://schemas.openxmlformats.org/drawingml/2006/main" xmlns:p="http://schemas.openxmlformats.org/presentationml/2006/main" xmlns:r="http://schemas.openxmlformats.org/officeDocument/2006/relationships">
+<p:sld xmlns:a="http://schemas.openxmlformats.org/drawingml/2006/main" xmlns:r="http://schemas.openxmlformats.org/officeDocument/2006/relationships" xmlns:p="http://schemas.openxmlformats.org/presentationml/2006/main">
   <p:cSld>
     <p:spTree>
       <p:nvGrpSpPr>
@@ -5971,7 +6106,14 @@
         <p:cNvGrpSpPr/>
         <p:nvPr/>
       </p:nvGrpSpPr>
-      <p:grpSpPr/>
+      <p:grpSpPr>
+        <a:xfrm>
+          <a:off x="0" y="0"/>
+          <a:ext cx="0" cy="0"/>
+          <a:chOff x="0" y="0"/>
+          <a:chExt cx="0" cy="0"/>
+        </a:xfrm>
+      </p:grpSpPr>
       <p:sp>
         <p:nvSpPr>
           <p:cNvPr id="2" name="Rectangle 1"/>
@@ -6014,6 +6156,7 @@
           <a:lstStyle/>
           <a:p>
             <a:pPr algn="ctr"/>
+            <a:endParaRPr/>
           </a:p>
         </p:txBody>
       </p:sp>
@@ -6055,7 +6198,7 @@
           </a:fontRef>
         </p:style>
         <p:txBody>
-          <a:bodyPr rtlCol="0" anchor="ctr" wrap="square"/>
+          <a:bodyPr wrap="square" rtlCol="0" anchor="ctr"/>
           <a:lstStyle/>
           <a:p>
             <a:pPr algn="ctr">
@@ -6136,6 +6279,7 @@
               </a:defRPr>
             </a:pPr>
             <a:r>
+              <a:rPr dirty="0"/>
               <a:t>C-Class: Mid-Range 64-Bit Controller Core</a:t>
             </a:r>
           </a:p>
@@ -6171,6 +6315,7 @@
               </a:defRPr>
             </a:pPr>
             <a:r>
+              <a:rPr dirty="0"/>
               <a:t>Industrial 64-bit core running up to 1 GHz, equipped with Sv39 MMU to boot full Linux distributions.</a:t>
             </a:r>
           </a:p>
@@ -6195,9 +6340,27 @@
                 <a:tableStyleId>{5C22544A-7EE6-4342-B048-85BDC9FD1C3A}</a:tableStyleId>
               </a:tblPr>
               <a:tblGrid>
-                <a:gridCol w="3383280"/>
-                <a:gridCol w="3657600"/>
-                <a:gridCol w="3657600"/>
+                <a:gridCol w="3383280">
+                  <a:extLst>
+                    <a:ext uri="{9D8B030D-6E8A-4147-A177-3AD203B41FA5}">
+                      <a16:colId xmlns:a16="http://schemas.microsoft.com/office/drawing/2014/main" val="20000"/>
+                    </a:ext>
+                  </a:extLst>
+                </a:gridCol>
+                <a:gridCol w="3657600">
+                  <a:extLst>
+                    <a:ext uri="{9D8B030D-6E8A-4147-A177-3AD203B41FA5}">
+                      <a16:colId xmlns:a16="http://schemas.microsoft.com/office/drawing/2014/main" val="20001"/>
+                    </a:ext>
+                  </a:extLst>
+                </a:gridCol>
+                <a:gridCol w="3657600">
+                  <a:extLst>
+                    <a:ext uri="{9D8B030D-6E8A-4147-A177-3AD203B41FA5}">
+                      <a16:colId xmlns:a16="http://schemas.microsoft.com/office/drawing/2014/main" val="20002"/>
+                    </a:ext>
+                  </a:extLst>
+                </a:gridCol>
               </a:tblGrid>
               <a:tr h="587828">
                 <a:tc>
@@ -6269,6 +6432,11 @@
                     </a:solidFill>
                   </a:tcPr>
                 </a:tc>
+                <a:extLst>
+                  <a:ext uri="{0D108BD9-81ED-4DB2-BD59-A6C34878D82A}">
+                    <a16:rowId xmlns:a16="http://schemas.microsoft.com/office/drawing/2014/main" val="10000"/>
+                  </a:ext>
+                </a:extLst>
               </a:tr>
               <a:tr h="587828">
                 <a:tc>
@@ -6340,6 +6508,11 @@
                     </a:solidFill>
                   </a:tcPr>
                 </a:tc>
+                <a:extLst>
+                  <a:ext uri="{0D108BD9-81ED-4DB2-BD59-A6C34878D82A}">
+                    <a16:rowId xmlns:a16="http://schemas.microsoft.com/office/drawing/2014/main" val="10001"/>
+                  </a:ext>
+                </a:extLst>
               </a:tr>
               <a:tr h="587828">
                 <a:tc>
@@ -6411,6 +6584,11 @@
                     </a:solidFill>
                   </a:tcPr>
                 </a:tc>
+                <a:extLst>
+                  <a:ext uri="{0D108BD9-81ED-4DB2-BD59-A6C34878D82A}">
+                    <a16:rowId xmlns:a16="http://schemas.microsoft.com/office/drawing/2014/main" val="10002"/>
+                  </a:ext>
+                </a:extLst>
               </a:tr>
               <a:tr h="587828">
                 <a:tc>
@@ -6482,6 +6660,11 @@
                     </a:solidFill>
                   </a:tcPr>
                 </a:tc>
+                <a:extLst>
+                  <a:ext uri="{0D108BD9-81ED-4DB2-BD59-A6C34878D82A}">
+                    <a16:rowId xmlns:a16="http://schemas.microsoft.com/office/drawing/2014/main" val="10003"/>
+                  </a:ext>
+                </a:extLst>
               </a:tr>
               <a:tr h="587828">
                 <a:tc>
@@ -6553,6 +6736,11 @@
                     </a:solidFill>
                   </a:tcPr>
                 </a:tc>
+                <a:extLst>
+                  <a:ext uri="{0D108BD9-81ED-4DB2-BD59-A6C34878D82A}">
+                    <a16:rowId xmlns:a16="http://schemas.microsoft.com/office/drawing/2014/main" val="10004"/>
+                  </a:ext>
+                </a:extLst>
               </a:tr>
               <a:tr h="587828">
                 <a:tc>
@@ -6624,6 +6812,11 @@
                     </a:solidFill>
                   </a:tcPr>
                 </a:tc>
+                <a:extLst>
+                  <a:ext uri="{0D108BD9-81ED-4DB2-BD59-A6C34878D82A}">
+                    <a16:rowId xmlns:a16="http://schemas.microsoft.com/office/drawing/2014/main" val="10005"/>
+                  </a:ext>
+                </a:extLst>
               </a:tr>
               <a:tr h="587832">
                 <a:tc>
@@ -6695,6 +6888,11 @@
                     </a:solidFill>
                   </a:tcPr>
                 </a:tc>
+                <a:extLst>
+                  <a:ext uri="{0D108BD9-81ED-4DB2-BD59-A6C34878D82A}">
+                    <a16:rowId xmlns:a16="http://schemas.microsoft.com/office/drawing/2014/main" val="10006"/>
+                  </a:ext>
+                </a:extLst>
               </a:tr>
             </a:tbl>
           </a:graphicData>
@@ -6744,7 +6942,7 @@
 </file>
 
 <file path=ppt/slides/slide4.xml><?xml version="1.0" encoding="utf-8"?>
-<p:sld xmlns:a="http://schemas.openxmlformats.org/drawingml/2006/main" xmlns:p="http://schemas.openxmlformats.org/presentationml/2006/main" xmlns:r="http://schemas.openxmlformats.org/officeDocument/2006/relationships">
+<p:sld xmlns:a="http://schemas.openxmlformats.org/drawingml/2006/main" xmlns:r="http://schemas.openxmlformats.org/officeDocument/2006/relationships" xmlns:p="http://schemas.openxmlformats.org/presentationml/2006/main">
   <p:cSld>
     <p:spTree>
       <p:nvGrpSpPr>
@@ -6752,7 +6950,14 @@
         <p:cNvGrpSpPr/>
         <p:nvPr/>
       </p:nvGrpSpPr>
-      <p:grpSpPr/>
+      <p:grpSpPr>
+        <a:xfrm>
+          <a:off x="0" y="0"/>
+          <a:ext cx="0" cy="0"/>
+          <a:chOff x="0" y="0"/>
+          <a:chExt cx="0" cy="0"/>
+        </a:xfrm>
+      </p:grpSpPr>
       <p:sp>
         <p:nvSpPr>
           <p:cNvPr id="2" name="Rectangle 1"/>
@@ -6795,6 +7000,7 @@
           <a:lstStyle/>
           <a:p>
             <a:pPr algn="ctr"/>
+            <a:endParaRPr/>
           </a:p>
         </p:txBody>
       </p:sp>
@@ -6836,7 +7042,7 @@
           </a:fontRef>
         </p:style>
         <p:txBody>
-          <a:bodyPr rtlCol="0" anchor="ctr" wrap="square"/>
+          <a:bodyPr wrap="square" rtlCol="0" anchor="ctr"/>
           <a:lstStyle/>
           <a:p>
             <a:pPr algn="ctr">
@@ -6995,7 +7201,7 @@
           </a:fontRef>
         </p:style>
         <p:txBody>
-          <a:bodyPr rtlCol="0" anchor="ctr" wrap="square"/>
+          <a:bodyPr wrap="square" rtlCol="0" anchor="ctr"/>
           <a:lstStyle/>
           <a:p>
             <a:pPr algn="ctr">
@@ -7021,6 +7227,7 @@
               <a:t>Target: Arty A7-35T FPGA</a:t>
             </a:r>
             <a:br/>
+            <a:endParaRPr/>
           </a:p>
           <a:p>
             <a:pPr>
@@ -7122,7 +7329,7 @@
           </a:fontRef>
         </p:style>
         <p:txBody>
-          <a:bodyPr rtlCol="0" anchor="ctr" wrap="square"/>
+          <a:bodyPr wrap="square" rtlCol="0" anchor="ctr"/>
           <a:lstStyle/>
           <a:p>
             <a:pPr algn="ctr">
@@ -7148,6 +7355,7 @@
               <a:t>Target: Arty A7-100T FPGA</a:t>
             </a:r>
             <a:br/>
+            <a:endParaRPr/>
           </a:p>
           <a:p>
             <a:pPr>
@@ -7249,7 +7457,7 @@
           </a:fontRef>
         </p:style>
         <p:txBody>
-          <a:bodyPr rtlCol="0" anchor="ctr" wrap="square"/>
+          <a:bodyPr wrap="square" rtlCol="0" anchor="ctr"/>
           <a:lstStyle/>
           <a:p>
             <a:pPr algn="ctr">
@@ -7275,6 +7483,7 @@
               <a:t>Target: Arty A7-100T FPGA</a:t>
             </a:r>
             <a:br/>
+            <a:endParaRPr/>
           </a:p>
           <a:p>
             <a:pPr>
@@ -7382,7 +7591,7 @@
 </file>
 
 <file path=ppt/slides/slide5.xml><?xml version="1.0" encoding="utf-8"?>
-<p:sld xmlns:a="http://schemas.openxmlformats.org/drawingml/2006/main" xmlns:p="http://schemas.openxmlformats.org/presentationml/2006/main" xmlns:r="http://schemas.openxmlformats.org/officeDocument/2006/relationships">
+<p:sld xmlns:a="http://schemas.openxmlformats.org/drawingml/2006/main" xmlns:r="http://schemas.openxmlformats.org/officeDocument/2006/relationships" xmlns:p="http://schemas.openxmlformats.org/presentationml/2006/main">
   <p:cSld>
     <p:spTree>
       <p:nvGrpSpPr>
@@ -7390,7 +7599,14 @@
         <p:cNvGrpSpPr/>
         <p:nvPr/>
       </p:nvGrpSpPr>
-      <p:grpSpPr/>
+      <p:grpSpPr>
+        <a:xfrm>
+          <a:off x="0" y="0"/>
+          <a:ext cx="0" cy="0"/>
+          <a:chOff x="0" y="0"/>
+          <a:chExt cx="0" cy="0"/>
+        </a:xfrm>
+      </p:grpSpPr>
       <p:sp>
         <p:nvSpPr>
           <p:cNvPr id="2" name="Rectangle 1"/>
@@ -7433,6 +7649,7 @@
           <a:lstStyle/>
           <a:p>
             <a:pPr algn="ctr"/>
+            <a:endParaRPr/>
           </a:p>
         </p:txBody>
       </p:sp>
@@ -7474,7 +7691,7 @@
           </a:fontRef>
         </p:style>
         <p:txBody>
-          <a:bodyPr rtlCol="0" anchor="ctr" wrap="square"/>
+          <a:bodyPr wrap="square" rtlCol="0" anchor="ctr"/>
           <a:lstStyle/>
           <a:p>
             <a:pPr algn="ctr">
@@ -7633,7 +7850,7 @@
           </a:fontRef>
         </p:style>
         <p:txBody>
-          <a:bodyPr rtlCol="0" anchor="ctr" wrap="square"/>
+          <a:bodyPr wrap="square" rtlCol="0" anchor="ctr"/>
           <a:lstStyle/>
           <a:p>
             <a:pPr algn="ctr">
@@ -7649,13 +7866,6 @@
           </a:p>
           <a:p>
             <a:br/>
-            <a:pPr>
-              <a:defRPr sz="1050" b="1">
-                <a:solidFill>
-                  <a:srgbClr val="0F172A"/>
-                </a:solidFill>
-              </a:defRPr>
-            </a:pPr>
             <a:r>
               <a:t>🔹 Channel A (MPSSE Engine): JTAG Hardware Debugging</a:t>
             </a:r>
@@ -7674,13 +7884,6 @@
           </a:p>
           <a:p>
             <a:br/>
-            <a:pPr>
-              <a:defRPr sz="1050" b="1">
-                <a:solidFill>
-                  <a:srgbClr val="0F172A"/>
-                </a:solidFill>
-              </a:defRPr>
-            </a:pPr>
             <a:r>
               <a:t>🔹 Channel B (Serial UART): System Console Terminal</a:t>
             </a:r>
@@ -7737,7 +7940,7 @@
           </a:fontRef>
         </p:style>
         <p:txBody>
-          <a:bodyPr rtlCol="0" anchor="ctr" wrap="square"/>
+          <a:bodyPr wrap="square" rtlCol="0" anchor="ctr"/>
           <a:lstStyle/>
           <a:p>
             <a:pPr algn="ctr">
@@ -7905,7 +8108,7 @@
 </file>
 
 <file path=ppt/slides/slide6.xml><?xml version="1.0" encoding="utf-8"?>
-<p:sld xmlns:a="http://schemas.openxmlformats.org/drawingml/2006/main" xmlns:p="http://schemas.openxmlformats.org/presentationml/2006/main" xmlns:r="http://schemas.openxmlformats.org/officeDocument/2006/relationships">
+<p:sld xmlns:a="http://schemas.openxmlformats.org/drawingml/2006/main" xmlns:r="http://schemas.openxmlformats.org/officeDocument/2006/relationships" xmlns:p="http://schemas.openxmlformats.org/presentationml/2006/main">
   <p:cSld>
     <p:spTree>
       <p:nvGrpSpPr>
@@ -7913,7 +8116,14 @@
         <p:cNvGrpSpPr/>
         <p:nvPr/>
       </p:nvGrpSpPr>
-      <p:grpSpPr/>
+      <p:grpSpPr>
+        <a:xfrm>
+          <a:off x="0" y="0"/>
+          <a:ext cx="0" cy="0"/>
+          <a:chOff x="0" y="0"/>
+          <a:chExt cx="0" cy="0"/>
+        </a:xfrm>
+      </p:grpSpPr>
       <p:sp>
         <p:nvSpPr>
           <p:cNvPr id="2" name="Rectangle 1"/>
@@ -7956,6 +8166,7 @@
           <a:lstStyle/>
           <a:p>
             <a:pPr algn="ctr"/>
+            <a:endParaRPr/>
           </a:p>
         </p:txBody>
       </p:sp>
@@ -7997,7 +8208,7 @@
           </a:fontRef>
         </p:style>
         <p:txBody>
-          <a:bodyPr rtlCol="0" anchor="ctr" wrap="square"/>
+          <a:bodyPr wrap="square" rtlCol="0" anchor="ctr"/>
           <a:lstStyle/>
           <a:p>
             <a:pPr algn="ctr">
@@ -8156,7 +8367,7 @@
           </a:fontRef>
         </p:style>
         <p:txBody>
-          <a:bodyPr rtlCol="0" anchor="ctr" wrap="square"/>
+          <a:bodyPr wrap="square" rtlCol="0" anchor="ctr"/>
           <a:lstStyle/>
           <a:p>
             <a:pPr algn="ctr">
@@ -8306,7 +8517,7 @@
           </a:fontRef>
         </p:style>
         <p:txBody>
-          <a:bodyPr rtlCol="0" anchor="ctr" wrap="square"/>
+          <a:bodyPr wrap="square" rtlCol="0" anchor="ctr"/>
           <a:lstStyle/>
           <a:p>
             <a:pPr algn="ctr">
@@ -8364,6 +8575,7 @@
                 </a:solidFill>
               </a:defRPr>
             </a:pPr>
+            <a:endParaRPr/>
           </a:p>
           <a:p>
             <a:pPr>
@@ -8421,6 +8633,7 @@
                 </a:solidFill>
               </a:defRPr>
             </a:pPr>
+            <a:endParaRPr/>
           </a:p>
           <a:p>
             <a:pPr>
@@ -8504,7 +8717,7 @@
 </file>
 
 <file path=ppt/slides/slide7.xml><?xml version="1.0" encoding="utf-8"?>
-<p:sld xmlns:a="http://schemas.openxmlformats.org/drawingml/2006/main" xmlns:p="http://schemas.openxmlformats.org/presentationml/2006/main" xmlns:r="http://schemas.openxmlformats.org/officeDocument/2006/relationships">
+<p:sld xmlns:a="http://schemas.openxmlformats.org/drawingml/2006/main" xmlns:r="http://schemas.openxmlformats.org/officeDocument/2006/relationships" xmlns:p="http://schemas.openxmlformats.org/presentationml/2006/main">
   <p:cSld>
     <p:spTree>
       <p:nvGrpSpPr>
@@ -8512,7 +8725,14 @@
         <p:cNvGrpSpPr/>
         <p:nvPr/>
       </p:nvGrpSpPr>
-      <p:grpSpPr/>
+      <p:grpSpPr>
+        <a:xfrm>
+          <a:off x="0" y="0"/>
+          <a:ext cx="0" cy="0"/>
+          <a:chOff x="0" y="0"/>
+          <a:chExt cx="0" cy="0"/>
+        </a:xfrm>
+      </p:grpSpPr>
       <p:sp>
         <p:nvSpPr>
           <p:cNvPr id="2" name="Rectangle 1"/>
@@ -8555,6 +8775,7 @@
           <a:lstStyle/>
           <a:p>
             <a:pPr algn="ctr"/>
+            <a:endParaRPr/>
           </a:p>
         </p:txBody>
       </p:sp>
@@ -8596,7 +8817,7 @@
           </a:fontRef>
         </p:style>
         <p:txBody>
-          <a:bodyPr rtlCol="0" anchor="ctr" wrap="square"/>
+          <a:bodyPr wrap="square" rtlCol="0" anchor="ctr"/>
           <a:lstStyle/>
           <a:p>
             <a:pPr algn="ctr">
@@ -8736,10 +8957,34 @@
                 <a:tableStyleId>{5C22544A-7EE6-4342-B048-85BDC9FD1C3A}</a:tableStyleId>
               </a:tblPr>
               <a:tblGrid>
-                <a:gridCol w="2011680"/>
-                <a:gridCol w="2926080"/>
-                <a:gridCol w="4114800"/>
-                <a:gridCol w="1645920"/>
+                <a:gridCol w="2011680">
+                  <a:extLst>
+                    <a:ext uri="{9D8B030D-6E8A-4147-A177-3AD203B41FA5}">
+                      <a16:colId xmlns:a16="http://schemas.microsoft.com/office/drawing/2014/main" val="20000"/>
+                    </a:ext>
+                  </a:extLst>
+                </a:gridCol>
+                <a:gridCol w="2926080">
+                  <a:extLst>
+                    <a:ext uri="{9D8B030D-6E8A-4147-A177-3AD203B41FA5}">
+                      <a16:colId xmlns:a16="http://schemas.microsoft.com/office/drawing/2014/main" val="20001"/>
+                    </a:ext>
+                  </a:extLst>
+                </a:gridCol>
+                <a:gridCol w="4114800">
+                  <a:extLst>
+                    <a:ext uri="{9D8B030D-6E8A-4147-A177-3AD203B41FA5}">
+                      <a16:colId xmlns:a16="http://schemas.microsoft.com/office/drawing/2014/main" val="20002"/>
+                    </a:ext>
+                  </a:extLst>
+                </a:gridCol>
+                <a:gridCol w="1645920">
+                  <a:extLst>
+                    <a:ext uri="{9D8B030D-6E8A-4147-A177-3AD203B41FA5}">
+                      <a16:colId xmlns:a16="http://schemas.microsoft.com/office/drawing/2014/main" val="20003"/>
+                    </a:ext>
+                  </a:extLst>
+                </a:gridCol>
               </a:tblGrid>
               <a:tr h="477520">
                 <a:tc>
@@ -8834,6 +9079,11 @@
                     </a:solidFill>
                   </a:tcPr>
                 </a:tc>
+                <a:extLst>
+                  <a:ext uri="{0D108BD9-81ED-4DB2-BD59-A6C34878D82A}">
+                    <a16:rowId xmlns:a16="http://schemas.microsoft.com/office/drawing/2014/main" val="10000"/>
+                  </a:ext>
+                </a:extLst>
               </a:tr>
               <a:tr h="477520">
                 <a:tc>
@@ -8928,6 +9178,11 @@
                     </a:solidFill>
                   </a:tcPr>
                 </a:tc>
+                <a:extLst>
+                  <a:ext uri="{0D108BD9-81ED-4DB2-BD59-A6C34878D82A}">
+                    <a16:rowId xmlns:a16="http://schemas.microsoft.com/office/drawing/2014/main" val="10001"/>
+                  </a:ext>
+                </a:extLst>
               </a:tr>
               <a:tr h="477520">
                 <a:tc>
@@ -9022,6 +9277,11 @@
                     </a:solidFill>
                   </a:tcPr>
                 </a:tc>
+                <a:extLst>
+                  <a:ext uri="{0D108BD9-81ED-4DB2-BD59-A6C34878D82A}">
+                    <a16:rowId xmlns:a16="http://schemas.microsoft.com/office/drawing/2014/main" val="10002"/>
+                  </a:ext>
+                </a:extLst>
               </a:tr>
               <a:tr h="477520">
                 <a:tc>
@@ -9116,6 +9376,11 @@
                     </a:solidFill>
                   </a:tcPr>
                 </a:tc>
+                <a:extLst>
+                  <a:ext uri="{0D108BD9-81ED-4DB2-BD59-A6C34878D82A}">
+                    <a16:rowId xmlns:a16="http://schemas.microsoft.com/office/drawing/2014/main" val="10003"/>
+                  </a:ext>
+                </a:extLst>
               </a:tr>
               <a:tr h="477520">
                 <a:tc>
@@ -9210,6 +9475,11 @@
                     </a:solidFill>
                   </a:tcPr>
                 </a:tc>
+                <a:extLst>
+                  <a:ext uri="{0D108BD9-81ED-4DB2-BD59-A6C34878D82A}">
+                    <a16:rowId xmlns:a16="http://schemas.microsoft.com/office/drawing/2014/main" val="10004"/>
+                  </a:ext>
+                </a:extLst>
               </a:tr>
               <a:tr h="477520">
                 <a:tc>
@@ -9304,6 +9574,11 @@
                     </a:solidFill>
                   </a:tcPr>
                 </a:tc>
+                <a:extLst>
+                  <a:ext uri="{0D108BD9-81ED-4DB2-BD59-A6C34878D82A}">
+                    <a16:rowId xmlns:a16="http://schemas.microsoft.com/office/drawing/2014/main" val="10005"/>
+                  </a:ext>
+                </a:extLst>
               </a:tr>
               <a:tr h="477520">
                 <a:tc>
@@ -9398,6 +9673,11 @@
                     </a:solidFill>
                   </a:tcPr>
                 </a:tc>
+                <a:extLst>
+                  <a:ext uri="{0D108BD9-81ED-4DB2-BD59-A6C34878D82A}">
+                    <a16:rowId xmlns:a16="http://schemas.microsoft.com/office/drawing/2014/main" val="10006"/>
+                  </a:ext>
+                </a:extLst>
               </a:tr>
               <a:tr h="477520">
                 <a:tc>
@@ -9492,6 +9772,11 @@
                     </a:solidFill>
                   </a:tcPr>
                 </a:tc>
+                <a:extLst>
+                  <a:ext uri="{0D108BD9-81ED-4DB2-BD59-A6C34878D82A}">
+                    <a16:rowId xmlns:a16="http://schemas.microsoft.com/office/drawing/2014/main" val="10007"/>
+                  </a:ext>
+                </a:extLst>
               </a:tr>
               <a:tr h="477520">
                 <a:tc>
@@ -9576,6 +9861,7 @@
                         </a:defRPr>
                       </a:pPr>
                       <a:r>
+                        <a:rPr dirty="0"/>
                         <a:t>Specific Target</a:t>
                       </a:r>
                     </a:p>
@@ -9586,6 +9872,11 @@
                     </a:solidFill>
                   </a:tcPr>
                 </a:tc>
+                <a:extLst>
+                  <a:ext uri="{0D108BD9-81ED-4DB2-BD59-A6C34878D82A}">
+                    <a16:rowId xmlns:a16="http://schemas.microsoft.com/office/drawing/2014/main" val="10008"/>
+                  </a:ext>
+                </a:extLst>
               </a:tr>
             </a:tbl>
           </a:graphicData>
@@ -9635,7 +9926,7 @@
 </file>
 
 <file path=ppt/slides/slide8.xml><?xml version="1.0" encoding="utf-8"?>
-<p:sld xmlns:a="http://schemas.openxmlformats.org/drawingml/2006/main" xmlns:p="http://schemas.openxmlformats.org/presentationml/2006/main" xmlns:r="http://schemas.openxmlformats.org/officeDocument/2006/relationships">
+<p:sld xmlns:a="http://schemas.openxmlformats.org/drawingml/2006/main" xmlns:r="http://schemas.openxmlformats.org/officeDocument/2006/relationships" xmlns:p="http://schemas.openxmlformats.org/presentationml/2006/main">
   <p:cSld>
     <p:spTree>
       <p:nvGrpSpPr>
@@ -9643,7 +9934,14 @@
         <p:cNvGrpSpPr/>
         <p:nvPr/>
       </p:nvGrpSpPr>
-      <p:grpSpPr/>
+      <p:grpSpPr>
+        <a:xfrm>
+          <a:off x="0" y="0"/>
+          <a:ext cx="0" cy="0"/>
+          <a:chOff x="0" y="0"/>
+          <a:chExt cx="0" cy="0"/>
+        </a:xfrm>
+      </p:grpSpPr>
       <p:sp>
         <p:nvSpPr>
           <p:cNvPr id="2" name="Rectangle 1"/>
@@ -9686,6 +9984,7 @@
           <a:lstStyle/>
           <a:p>
             <a:pPr algn="ctr"/>
+            <a:endParaRPr/>
           </a:p>
         </p:txBody>
       </p:sp>
@@ -9727,7 +10026,7 @@
           </a:fontRef>
         </p:style>
         <p:txBody>
-          <a:bodyPr rtlCol="0" anchor="ctr" wrap="square"/>
+          <a:bodyPr wrap="square" rtlCol="0" anchor="ctr"/>
           <a:lstStyle/>
           <a:p>
             <a:pPr algn="ctr">
@@ -9886,7 +10185,7 @@
           </a:fontRef>
         </p:style>
         <p:txBody>
-          <a:bodyPr rtlCol="0" anchor="ctr" wrap="square"/>
+          <a:bodyPr wrap="square" rtlCol="0" anchor="ctr"/>
           <a:lstStyle/>
           <a:p>
             <a:pPr algn="ctr">
@@ -9902,13 +10201,6 @@
           </a:p>
           <a:p>
             <a:br/>
-            <a:pPr>
-              <a:defRPr sz="1000" b="1">
-                <a:solidFill>
-                  <a:srgbClr val="0F172A"/>
-                </a:solidFill>
-              </a:defRPr>
-            </a:pPr>
             <a:r>
               <a:t>📦 Application Layer</a:t>
             </a:r>
@@ -9927,13 +10219,6 @@
           </a:p>
           <a:p>
             <a:br/>
-            <a:pPr>
-              <a:defRPr sz="1000" b="1">
-                <a:solidFill>
-                  <a:srgbClr val="0F172A"/>
-                </a:solidFill>
-              </a:defRPr>
-            </a:pPr>
             <a:r>
               <a:t>📦 OS / Middleware Layer</a:t>
             </a:r>
@@ -9952,13 +10237,6 @@
           </a:p>
           <a:p>
             <a:br/>
-            <a:pPr>
-              <a:defRPr sz="1000" b="1">
-                <a:solidFill>
-                  <a:srgbClr val="0F172A"/>
-                </a:solidFill>
-              </a:defRPr>
-            </a:pPr>
             <a:r>
               <a:t>📦 Board Support Package (BSP)</a:t>
             </a:r>
@@ -9977,13 +10255,6 @@
           </a:p>
           <a:p>
             <a:br/>
-            <a:pPr>
-              <a:defRPr sz="1000" b="1">
-                <a:solidFill>
-                  <a:srgbClr val="0F172A"/>
-                </a:solidFill>
-              </a:defRPr>
-            </a:pPr>
             <a:r>
               <a:t>📦 Low-Level Architecture</a:t>
             </a:r>
@@ -10002,13 +10273,6 @@
           </a:p>
           <a:p>
             <a:br/>
-            <a:pPr>
-              <a:defRPr sz="1000" b="1">
-                <a:solidFill>
-                  <a:srgbClr val="0F172A"/>
-                </a:solidFill>
-              </a:defRPr>
-            </a:pPr>
             <a:r>
               <a:t>📦 Physical Hardware</a:t>
             </a:r>
@@ -10065,7 +10329,7 @@
           </a:fontRef>
         </p:style>
         <p:txBody>
-          <a:bodyPr rtlCol="0" anchor="ctr" wrap="square"/>
+          <a:bodyPr wrap="square" rtlCol="0" anchor="ctr"/>
           <a:lstStyle/>
           <a:p>
             <a:pPr algn="ctr">
@@ -10147,6 +10411,7 @@
                 </a:solidFill>
               </a:defRPr>
             </a:pPr>
+            <a:endParaRPr/>
           </a:p>
           <a:p>
             <a:pPr>
@@ -10192,6 +10457,7 @@
                 </a:solidFill>
               </a:defRPr>
             </a:pPr>
+            <a:endParaRPr/>
           </a:p>
           <a:p>
             <a:pPr>
@@ -10275,7 +10541,7 @@
 </file>
 
 <file path=ppt/slides/slide9.xml><?xml version="1.0" encoding="utf-8"?>
-<p:sld xmlns:a="http://schemas.openxmlformats.org/drawingml/2006/main" xmlns:p="http://schemas.openxmlformats.org/presentationml/2006/main" xmlns:r="http://schemas.openxmlformats.org/officeDocument/2006/relationships">
+<p:sld xmlns:a="http://schemas.openxmlformats.org/drawingml/2006/main" xmlns:r="http://schemas.openxmlformats.org/officeDocument/2006/relationships" xmlns:p="http://schemas.openxmlformats.org/presentationml/2006/main">
   <p:cSld>
     <p:spTree>
       <p:nvGrpSpPr>
@@ -10283,7 +10549,14 @@
         <p:cNvGrpSpPr/>
         <p:nvPr/>
       </p:nvGrpSpPr>
-      <p:grpSpPr/>
+      <p:grpSpPr>
+        <a:xfrm>
+          <a:off x="0" y="0"/>
+          <a:ext cx="0" cy="0"/>
+          <a:chOff x="0" y="0"/>
+          <a:chExt cx="0" cy="0"/>
+        </a:xfrm>
+      </p:grpSpPr>
       <p:sp>
         <p:nvSpPr>
           <p:cNvPr id="2" name="Rectangle 1"/>
@@ -10326,6 +10599,7 @@
           <a:lstStyle/>
           <a:p>
             <a:pPr algn="ctr"/>
+            <a:endParaRPr/>
           </a:p>
         </p:txBody>
       </p:sp>
@@ -10367,7 +10641,7 @@
           </a:fontRef>
         </p:style>
         <p:txBody>
-          <a:bodyPr rtlCol="0" anchor="ctr" wrap="square"/>
+          <a:bodyPr wrap="square" rtlCol="0" anchor="ctr"/>
           <a:lstStyle/>
           <a:p>
             <a:pPr algn="ctr">
@@ -10526,7 +10800,7 @@
           </a:fontRef>
         </p:style>
         <p:txBody>
-          <a:bodyPr rtlCol="0" anchor="ctr" wrap="square"/>
+          <a:bodyPr wrap="square" rtlCol="0" anchor="ctr"/>
           <a:lstStyle/>
           <a:p>
             <a:pPr algn="ctr">
@@ -10542,13 +10816,6 @@
           </a:p>
           <a:p>
             <a:br/>
-            <a:pPr>
-              <a:defRPr sz="1000" b="1">
-                <a:solidFill>
-                  <a:srgbClr val="0F172A"/>
-                </a:solidFill>
-              </a:defRPr>
-            </a:pPr>
             <a:r>
               <a:t>📌 1. Choose Peripheral Directory</a:t>
             </a:r>
@@ -10567,13 +10834,6 @@
           </a:p>
           <a:p>
             <a:br/>
-            <a:pPr>
-              <a:defRPr sz="1000" b="1">
-                <a:solidFill>
-                  <a:srgbClr val="0F172A"/>
-                </a:solidFill>
-              </a:defRPr>
-            </a:pPr>
             <a:r>
               <a:t>📌 2. Create Application Folder &amp; Source</a:t>
             </a:r>
@@ -10592,13 +10852,6 @@
           </a:p>
           <a:p>
             <a:br/>
-            <a:pPr>
-              <a:defRPr sz="1000" b="1">
-                <a:solidFill>
-                  <a:srgbClr val="0F172A"/>
-                </a:solidFill>
-              </a:defRPr>
-            </a:pPr>
             <a:r>
               <a:t>📌 3. Create Local Makefile</a:t>
             </a:r>
@@ -10617,13 +10870,6 @@
           </a:p>
           <a:p>
             <a:br/>
-            <a:pPr>
-              <a:defRPr sz="1000" b="1">
-                <a:solidFill>
-                  <a:srgbClr val="0F172A"/>
-                </a:solidFill>
-              </a:defRPr>
-            </a:pPr>
             <a:r>
               <a:t>📌 4. Register in Master Makefile</a:t>
             </a:r>
@@ -10680,7 +10926,7 @@
           </a:fontRef>
         </p:style>
         <p:txBody>
-          <a:bodyPr rtlCol="0" anchor="ctr" wrap="square"/>
+          <a:bodyPr wrap="square" rtlCol="0" anchor="ctr"/>
           <a:lstStyle/>
           <a:p>
             <a:pPr algn="ctr">
@@ -10726,6 +10972,7 @@
                 </a:solidFill>
               </a:defRPr>
             </a:pPr>
+            <a:endParaRPr/>
           </a:p>
           <a:p>
             <a:pPr>
@@ -10759,6 +11006,7 @@
                 </a:solidFill>
               </a:defRPr>
             </a:pPr>
+            <a:endParaRPr/>
           </a:p>
           <a:p>
             <a:pPr>
@@ -10792,6 +11040,7 @@
                 </a:solidFill>
               </a:defRPr>
             </a:pPr>
+            <a:endParaRPr/>
           </a:p>
           <a:p>
             <a:pPr>
@@ -10825,6 +11074,7 @@
                 </a:solidFill>
               </a:defRPr>
             </a:pPr>
+            <a:endParaRPr/>
           </a:p>
           <a:p>
             <a:pPr>

</xml_diff>